<commit_message>
minor fix in courses/31.key with pptx and pdf
</commit_message>
<xml_diff>
--- a/courses/pptx/31.pptx
+++ b/courses/pptx/31.pptx
@@ -4669,7 +4669,7 @@
               </a:defRPr>
             </a:pPr>
             <a:r>
-              <a:t>let foo = &lt;T&gt; (a: T): T { return a }</a:t>
+              <a:t>let foo = &lt;T&gt; (a: T): T =&gt; { return a }</a:t>
             </a:r>
           </a:p>
           <a:p>
@@ -4689,7 +4689,7 @@
               </a:defRPr>
             </a:pPr>
             <a:r>
-              <a:t>let MyClass = class &lt;T&gt; { a: T }</a:t>
+              <a:t>let MyClass = class &lt;T&gt; { a!: T }</a:t>
             </a:r>
           </a:p>
           <a:p>

</xml_diff>